<commit_message>
Fix final presentation schema wording
</commit_message>
<xml_diff>
--- a/Semantic_API_Request_Diagnosis_Final_Designed_v6_submission_ready.pptx
+++ b/Semantic_API_Request_Diagnosis_Final_Designed_v6_submission_ready.pptx
@@ -2,28 +2,28 @@
 <file path=ppt/presentation.xml><?xml version="1.0" encoding="utf-8"?>
 <p:presentation xmlns:p="http://schemas.openxmlformats.org/presentationml/2006/main">
   <p:sldMasterIdLst>
-    <p:sldMasterId xmlns:r="http://schemas.openxmlformats.org/officeDocument/2006/relationships" id="2147483648" r:id="Rf77ff0d12b21492a"/>
+    <p:sldMasterId xmlns:r="http://schemas.openxmlformats.org/officeDocument/2006/relationships" id="2147483648" r:id="R258d6cbfe258488b"/>
   </p:sldMasterIdLst>
   <p:notesMasterIdLst>
-    <p:notesMasterId xmlns:r="http://schemas.openxmlformats.org/officeDocument/2006/relationships" r:id="R5336155483734e5b"/>
+    <p:notesMasterId xmlns:r="http://schemas.openxmlformats.org/officeDocument/2006/relationships" r:id="R1efe200755444334"/>
   </p:notesMasterIdLst>
   <p:sldIdLst>
-    <p:sldId xmlns:r="http://schemas.openxmlformats.org/officeDocument/2006/relationships" id="256" r:id="R66a9a03f63bd465c"/>
-    <p:sldId xmlns:r="http://schemas.openxmlformats.org/officeDocument/2006/relationships" id="257" r:id="R3164a6b6e20b48ca"/>
-    <p:sldId xmlns:r="http://schemas.openxmlformats.org/officeDocument/2006/relationships" id="258" r:id="Rf0855e89eab541b7"/>
-    <p:sldId xmlns:r="http://schemas.openxmlformats.org/officeDocument/2006/relationships" id="259" r:id="Re4e2207b810e4aa6"/>
-    <p:sldId xmlns:r="http://schemas.openxmlformats.org/officeDocument/2006/relationships" id="260" r:id="Rc2c374ed3d8b49c9"/>
-    <p:sldId xmlns:r="http://schemas.openxmlformats.org/officeDocument/2006/relationships" id="261" r:id="R14b9a9301b37421a"/>
-    <p:sldId xmlns:r="http://schemas.openxmlformats.org/officeDocument/2006/relationships" id="262" r:id="Ra8c52faf71584154"/>
-    <p:sldId xmlns:r="http://schemas.openxmlformats.org/officeDocument/2006/relationships" id="263" r:id="Rf80f91d81eed4148"/>
-    <p:sldId xmlns:r="http://schemas.openxmlformats.org/officeDocument/2006/relationships" id="264" r:id="Rc438a6f96fd5471e"/>
-    <p:sldId xmlns:r="http://schemas.openxmlformats.org/officeDocument/2006/relationships" id="265" r:id="Rd4a4759ea3df4419"/>
-    <p:sldId xmlns:r="http://schemas.openxmlformats.org/officeDocument/2006/relationships" id="266" r:id="Re2bafda89db34511"/>
-    <p:sldId xmlns:r="http://schemas.openxmlformats.org/officeDocument/2006/relationships" id="267" r:id="R8b7c09f3ae674b04"/>
-    <p:sldId xmlns:r="http://schemas.openxmlformats.org/officeDocument/2006/relationships" id="268" r:id="R0e6a434faa1c48ca"/>
-    <p:sldId xmlns:r="http://schemas.openxmlformats.org/officeDocument/2006/relationships" id="269" r:id="R3c9817ec514c4bf6"/>
-    <p:sldId xmlns:r="http://schemas.openxmlformats.org/officeDocument/2006/relationships" id="270" r:id="R24335fd6d8f240f1"/>
-    <p:sldId xmlns:r="http://schemas.openxmlformats.org/officeDocument/2006/relationships" id="271" r:id="R0c6ea8a2321f49ba"/>
+    <p:sldId xmlns:r="http://schemas.openxmlformats.org/officeDocument/2006/relationships" id="256" r:id="R485bb3a525da4e23"/>
+    <p:sldId xmlns:r="http://schemas.openxmlformats.org/officeDocument/2006/relationships" id="257" r:id="Ree8cd585f6634787"/>
+    <p:sldId xmlns:r="http://schemas.openxmlformats.org/officeDocument/2006/relationships" id="258" r:id="Raa3dd2476e914907"/>
+    <p:sldId xmlns:r="http://schemas.openxmlformats.org/officeDocument/2006/relationships" id="259" r:id="R20847e6af545480b"/>
+    <p:sldId xmlns:r="http://schemas.openxmlformats.org/officeDocument/2006/relationships" id="260" r:id="Raf690972cd3740b7"/>
+    <p:sldId xmlns:r="http://schemas.openxmlformats.org/officeDocument/2006/relationships" id="261" r:id="Rc97891f9f0cb4f2b"/>
+    <p:sldId xmlns:r="http://schemas.openxmlformats.org/officeDocument/2006/relationships" id="262" r:id="R21ee891b077a40ad"/>
+    <p:sldId xmlns:r="http://schemas.openxmlformats.org/officeDocument/2006/relationships" id="263" r:id="R2367823a06d74323"/>
+    <p:sldId xmlns:r="http://schemas.openxmlformats.org/officeDocument/2006/relationships" id="264" r:id="R560beeb940834790"/>
+    <p:sldId xmlns:r="http://schemas.openxmlformats.org/officeDocument/2006/relationships" id="265" r:id="R7840da790fa24f83"/>
+    <p:sldId xmlns:r="http://schemas.openxmlformats.org/officeDocument/2006/relationships" id="266" r:id="Rc6a22d2e69b94713"/>
+    <p:sldId xmlns:r="http://schemas.openxmlformats.org/officeDocument/2006/relationships" id="267" r:id="Rdfa87ff4a0874924"/>
+    <p:sldId xmlns:r="http://schemas.openxmlformats.org/officeDocument/2006/relationships" id="268" r:id="R10c2fbcb79fc4af9"/>
+    <p:sldId xmlns:r="http://schemas.openxmlformats.org/officeDocument/2006/relationships" id="269" r:id="Rd8b5d39d8dc440e3"/>
+    <p:sldId xmlns:r="http://schemas.openxmlformats.org/officeDocument/2006/relationships" id="270" r:id="Rf4e2050d94354ed9"/>
+    <p:sldId xmlns:r="http://schemas.openxmlformats.org/officeDocument/2006/relationships" id="271" r:id="R59045b5a8b0d41bd"/>
   </p:sldIdLst>
   <p:sldSz cx="12192000" cy="6858000"/>
   <p:notesSz cx="6858000" cy="9144000"/>
@@ -1629,8 +1629,8 @@
   </p:cSld>
   <p:clrMap bg1="lt1" tx1="dk1" bg2="lt2" tx2="dk2" accent1="accent1" accent2="accent2" accent3="accent3" accent4="accent4" accent5="accent5" accent6="accent6" hlink="hlink" folHlink="folHlink"/>
   <p:sldLayoutIdLst>
-    <p:sldLayoutId xmlns:r="http://schemas.openxmlformats.org/officeDocument/2006/relationships" id="2147483649" r:id="R3c4aa383adf446a4"/>
-    <p:sldLayoutId xmlns:r="http://schemas.openxmlformats.org/officeDocument/2006/relationships" id="2147483650" r:id="R0c4489defb22468f"/>
+    <p:sldLayoutId xmlns:r="http://schemas.openxmlformats.org/officeDocument/2006/relationships" id="2147483649" r:id="R46685a4d5cc84591"/>
+    <p:sldLayoutId xmlns:r="http://schemas.openxmlformats.org/officeDocument/2006/relationships" id="2147483650" r:id="R9ff9fec638dd4774"/>
   </p:sldLayoutIdLst>
   <p:hf sldNum="0" hdr="0" ftr="0" dt="0"/>
   <p:txStyles>
@@ -10939,7 +10939,7 @@
         <p:spPr>
           <a:xfrm xmlns:a="http://schemas.openxmlformats.org/drawingml/2006/main">
             <a:off x="1060704" y="4571085"/>
-            <a:ext cx="1984248" cy="98755"/>
+            <a:ext cx="1984248" cy="121920"/>
           </a:xfrm>
           <a:prstGeom xmlns:a="http://schemas.openxmlformats.org/drawingml/2006/main" prst="rect">
             <a:avLst/>
@@ -10964,7 +10964,7 @@
               </a:defRPr>
             </a:pPr>
             <a:r>
-              <a:t>unseen_test</a:t>
+              <a:t>unseen_family_test</a:t>
             </a:r>
           </a:p>
         </p:txBody>
@@ -11449,7 +11449,7 @@
         <p:spPr>
           <a:xfrm xmlns:a="http://schemas.openxmlformats.org/drawingml/2006/main">
             <a:off x="1060704" y="4742992"/>
-            <a:ext cx="1984248" cy="98755"/>
+            <a:ext cx="1984248" cy="121920"/>
           </a:xfrm>
           <a:prstGeom xmlns:a="http://schemas.openxmlformats.org/drawingml/2006/main" prst="rect">
             <a:avLst/>
@@ -11474,7 +11474,7 @@
               </a:defRPr>
             </a:pPr>
             <a:r>
-              <a:t>unseen_test</a:t>
+              <a:t>unseen_family_test</a:t>
             </a:r>
           </a:p>
         </p:txBody>
@@ -30029,7 +30029,7 @@
         </p:spPr>
         <p:txBody>
           <a:bodyPr xmlns:a="http://schemas.openxmlformats.org/drawingml/2006/main" wrap="square" lIns="0" tIns="0" rIns="0" bIns="0" anchor="ctr">
-            <a:normAutofit/>
+            <a:normAutofit fontScale="100000"/>
           </a:bodyPr>
           <a:lstStyle xmlns:a="http://schemas.openxmlformats.org/drawingml/2006/main"/>
           <a:p xmlns:a="http://schemas.openxmlformats.org/drawingml/2006/main">
@@ -30125,7 +30125,7 @@
                 <a:ea typeface="Courier New"/>
                 <a:cs typeface="Courier New"/>
               </a:rPr>
-              <a:t>severity: high</a:t>
+              <a:t>severity_bucket: high</a:t>
             </a:r>
           </a:p>
         </p:txBody>

</xml_diff>